<commit_message>
docs: add cryptpad link
</commit_message>
<xml_diff>
--- a/site/public/slides/counterspy-2026-ready.pptx
+++ b/site/public/slides/counterspy-2026-ready.pptx
@@ -400,7 +400,7 @@
             <a:pPr indent="0" algn="r">
               <a:buNone/>
             </a:pPr>
-            <a:fld id="{09DC04E1-CA15-4A16-9439-0553F46813BF}" type="slidenum">
+            <a:fld id="{F4269C3D-5FE0-48D5-AEE8-BC61A223B808}" type="slidenum">
               <a:rPr b="0" lang="en-US" sz="1400" spc="-1" strike="noStrike">
                 <a:solidFill>
                   <a:srgbClr val="000000"/>
@@ -564,7 +564,7 @@
               </a:lnSpc>
               <a:buNone/>
             </a:pPr>
-            <a:fld id="{8D166B83-FFE2-4041-840F-EF74EDE6E060}" type="slidenum">
+            <a:fld id="{1851E61E-D8FD-480D-BA14-7062939FEA5F}" type="slidenum">
               <a:rPr b="0" lang="en-US" sz="1200" spc="-1" strike="noStrike">
                 <a:solidFill>
                   <a:srgbClr val="000000"/>
@@ -727,7 +727,7 @@
               </a:lnSpc>
               <a:buNone/>
             </a:pPr>
-            <a:fld id="{BFDF4E26-CA6A-446A-8349-EE2AB57DD2BA}" type="slidenum">
+            <a:fld id="{C5E86652-6EFB-4984-96CF-CB860011E17C}" type="slidenum">
               <a:rPr b="0" lang="en-US" sz="1200" spc="-1" strike="noStrike">
                 <a:solidFill>
                   <a:srgbClr val="000000"/>
@@ -890,7 +890,7 @@
               </a:lnSpc>
               <a:buNone/>
             </a:pPr>
-            <a:fld id="{579C2637-7F8C-475C-AAA4-301A7360E1EF}" type="slidenum">
+            <a:fld id="{6CCDD6EC-D359-4E5B-B99B-5A7644504321}" type="slidenum">
               <a:rPr b="0" lang="en-US" sz="1200" spc="-1" strike="noStrike">
                 <a:solidFill>
                   <a:srgbClr val="000000"/>
@@ -1053,7 +1053,7 @@
               </a:lnSpc>
               <a:buNone/>
             </a:pPr>
-            <a:fld id="{21C8FDF5-B635-42EA-8433-7DD91D552422}" type="slidenum">
+            <a:fld id="{A86C925A-5F22-4E7A-AC21-D1648585B5D8}" type="slidenum">
               <a:rPr b="0" lang="en-US" sz="1200" spc="-1" strike="noStrike">
                 <a:solidFill>
                   <a:srgbClr val="000000"/>
@@ -1216,7 +1216,7 @@
               </a:lnSpc>
               <a:buNone/>
             </a:pPr>
-            <a:fld id="{041675F7-084B-473A-B871-7F0674C072F1}" type="slidenum">
+            <a:fld id="{5D573DCB-3AE1-4468-B32E-6D6011406554}" type="slidenum">
               <a:rPr b="0" lang="en-US" sz="1200" spc="-1" strike="noStrike">
                 <a:solidFill>
                   <a:srgbClr val="000000"/>
@@ -1379,7 +1379,7 @@
               </a:lnSpc>
               <a:buNone/>
             </a:pPr>
-            <a:fld id="{C75A49EB-9F00-43A6-98EB-DA9C6ED99AC3}" type="slidenum">
+            <a:fld id="{BC14D097-8E79-4CF7-82E9-95843C27F5BF}" type="slidenum">
               <a:rPr b="0" lang="en-US" sz="1200" spc="-1" strike="noStrike">
                 <a:solidFill>
                   <a:srgbClr val="000000"/>
@@ -1542,7 +1542,7 @@
               </a:lnSpc>
               <a:buNone/>
             </a:pPr>
-            <a:fld id="{BBD43F9B-8074-49D5-8B92-BA3BC2B03091}" type="slidenum">
+            <a:fld id="{95CFEE86-82CA-4E5F-BBD3-1E3FD1349B05}" type="slidenum">
               <a:rPr b="0" lang="en-US" sz="1200" spc="-1" strike="noStrike">
                 <a:solidFill>
                   <a:srgbClr val="000000"/>
@@ -1705,7 +1705,7 @@
               </a:lnSpc>
               <a:buNone/>
             </a:pPr>
-            <a:fld id="{1B909FE6-87D8-47ED-8B20-C6021DBD7462}" type="slidenum">
+            <a:fld id="{C7E21A0A-A7B4-49B9-9848-E20031DDE0C4}" type="slidenum">
               <a:rPr b="0" lang="en-US" sz="1200" spc="-1" strike="noStrike">
                 <a:solidFill>
                   <a:srgbClr val="000000"/>
@@ -1868,7 +1868,7 @@
               </a:lnSpc>
               <a:buNone/>
             </a:pPr>
-            <a:fld id="{FEE5576C-5E23-403F-B9A3-32EB57119E2A}" type="slidenum">
+            <a:fld id="{C679E090-F6E6-49EC-9FD1-A35AFE331648}" type="slidenum">
               <a:rPr b="0" lang="en-US" sz="1200" spc="-1" strike="noStrike">
                 <a:solidFill>
                   <a:srgbClr val="000000"/>
@@ -2031,7 +2031,7 @@
               </a:lnSpc>
               <a:buNone/>
             </a:pPr>
-            <a:fld id="{26DE21B9-D547-4753-8310-384383C49858}" type="slidenum">
+            <a:fld id="{D56D3653-AA39-429A-9C84-50995C5918CD}" type="slidenum">
               <a:rPr b="0" lang="en-US" sz="1200" spc="-1" strike="noStrike">
                 <a:solidFill>
                   <a:srgbClr val="000000"/>
@@ -2194,7 +2194,7 @@
               </a:lnSpc>
               <a:buNone/>
             </a:pPr>
-            <a:fld id="{E500A1DD-2DD5-4000-8499-665E11CE0E1D}" type="slidenum">
+            <a:fld id="{AA421576-DDF4-435D-8117-484B007FC28F}" type="slidenum">
               <a:rPr b="0" lang="en-US" sz="1200" spc="-1" strike="noStrike">
                 <a:solidFill>
                   <a:srgbClr val="000000"/>
@@ -2357,7 +2357,7 @@
               </a:lnSpc>
               <a:buNone/>
             </a:pPr>
-            <a:fld id="{232122C7-1066-48B1-9FE9-72F48FC839D2}" type="slidenum">
+            <a:fld id="{692D9C95-B0F7-4895-81D2-9C11FC594F7D}" type="slidenum">
               <a:rPr b="0" lang="en-US" sz="1200" spc="-1" strike="noStrike">
                 <a:solidFill>
                   <a:srgbClr val="000000"/>
@@ -2520,7 +2520,7 @@
               </a:lnSpc>
               <a:buNone/>
             </a:pPr>
-            <a:fld id="{4EA9AB4D-5DBA-4B4F-A05A-F35BB1775C6D}" type="slidenum">
+            <a:fld id="{51012B76-9655-46AD-BCBA-B6BC2E79C840}" type="slidenum">
               <a:rPr b="0" lang="en-US" sz="1200" spc="-1" strike="noStrike">
                 <a:solidFill>
                   <a:srgbClr val="000000"/>
@@ -2683,7 +2683,7 @@
               </a:lnSpc>
               <a:buNone/>
             </a:pPr>
-            <a:fld id="{89D3F6F1-AA36-4501-A4DE-B806600315FF}" type="slidenum">
+            <a:fld id="{F6B050C6-7555-4282-9E16-F6BF752DA41E}" type="slidenum">
               <a:rPr b="0" lang="en-US" sz="1200" spc="-1" strike="noStrike">
                 <a:solidFill>
                   <a:srgbClr val="000000"/>
@@ -2846,7 +2846,7 @@
               </a:lnSpc>
               <a:buNone/>
             </a:pPr>
-            <a:fld id="{DAB71D34-DBE3-4CF2-996B-BC9012CFD578}" type="slidenum">
+            <a:fld id="{B0001B54-8902-418F-9BBC-9341A7CA837A}" type="slidenum">
               <a:rPr b="0" lang="en-US" sz="1200" spc="-1" strike="noStrike">
                 <a:solidFill>
                   <a:srgbClr val="000000"/>
@@ -3009,7 +3009,7 @@
               </a:lnSpc>
               <a:buNone/>
             </a:pPr>
-            <a:fld id="{B45DE9D0-8E43-4F83-80A8-683F22349443}" type="slidenum">
+            <a:fld id="{7C80EC48-4A48-41FC-912C-FF3F51C09631}" type="slidenum">
               <a:rPr b="0" lang="en-US" sz="1200" spc="-1" strike="noStrike">
                 <a:solidFill>
                   <a:srgbClr val="000000"/>
@@ -3172,7 +3172,7 @@
               </a:lnSpc>
               <a:buNone/>
             </a:pPr>
-            <a:fld id="{BAA606C1-CD9E-4A7D-BA8D-FDA74AFD59E2}" type="slidenum">
+            <a:fld id="{D017752D-921B-4030-A019-9E4D4AD3581F}" type="slidenum">
               <a:rPr b="0" lang="en-US" sz="1200" spc="-1" strike="noStrike">
                 <a:solidFill>
                   <a:srgbClr val="000000"/>
@@ -3335,7 +3335,7 @@
               </a:lnSpc>
               <a:buNone/>
             </a:pPr>
-            <a:fld id="{B8AD7B76-A47A-4301-803D-6CD03EB4DA3E}" type="slidenum">
+            <a:fld id="{7D64000D-14FC-4914-809C-1EFF8068014B}" type="slidenum">
               <a:rPr b="0" lang="en-US" sz="1200" spc="-1" strike="noStrike">
                 <a:solidFill>
                   <a:srgbClr val="000000"/>
@@ -3498,7 +3498,7 @@
               </a:lnSpc>
               <a:buNone/>
             </a:pPr>
-            <a:fld id="{A3037B9B-3404-4B4A-8197-100F69D33654}" type="slidenum">
+            <a:fld id="{FD8179F6-328A-4327-AAD5-88961EA87784}" type="slidenum">
               <a:rPr b="0" lang="en-US" sz="1200" spc="-1" strike="noStrike">
                 <a:solidFill>
                   <a:srgbClr val="000000"/>
@@ -3661,7 +3661,7 @@
               </a:lnSpc>
               <a:buNone/>
             </a:pPr>
-            <a:fld id="{614585BF-6755-4314-BA1F-1530B44C0791}" type="slidenum">
+            <a:fld id="{AA5B7418-1293-413F-8087-F6156DE8EEF5}" type="slidenum">
               <a:rPr b="0" lang="en-US" sz="1200" spc="-1" strike="noStrike">
                 <a:solidFill>
                   <a:srgbClr val="000000"/>
@@ -3824,7 +3824,7 @@
               </a:lnSpc>
               <a:buNone/>
             </a:pPr>
-            <a:fld id="{3581732E-4813-4E9F-9946-58299F243905}" type="slidenum">
+            <a:fld id="{AB108E90-0BCF-4402-86D7-2AD013B1CBBE}" type="slidenum">
               <a:rPr b="0" lang="en-US" sz="1200" spc="-1" strike="noStrike">
                 <a:solidFill>
                   <a:srgbClr val="000000"/>
@@ -3987,7 +3987,7 @@
               </a:lnSpc>
               <a:buNone/>
             </a:pPr>
-            <a:fld id="{3CE6028D-9FF8-4B7F-A742-7BCE546F134E}" type="slidenum">
+            <a:fld id="{2AD94867-1F00-49D5-BC19-C5EE8143935D}" type="slidenum">
               <a:rPr b="0" lang="en-US" sz="1200" spc="-1" strike="noStrike">
                 <a:solidFill>
                   <a:srgbClr val="000000"/>
@@ -4150,7 +4150,7 @@
               </a:lnSpc>
               <a:buNone/>
             </a:pPr>
-            <a:fld id="{D7AA397D-07AF-47F7-8CFD-84A1BF5DB381}" type="slidenum">
+            <a:fld id="{A4ED5BC2-BD13-4D32-B2E8-4B66123720D7}" type="slidenum">
               <a:rPr b="0" lang="en-US" sz="1200" spc="-1" strike="noStrike">
                 <a:solidFill>
                   <a:srgbClr val="000000"/>
@@ -4313,7 +4313,7 @@
               </a:lnSpc>
               <a:buNone/>
             </a:pPr>
-            <a:fld id="{B4CAE86C-8633-4AD4-9A5B-18A7D9B6D31B}" type="slidenum">
+            <a:fld id="{A45037E7-768A-4D85-B47D-7571F911CC32}" type="slidenum">
               <a:rPr b="0" lang="en-US" sz="1200" spc="-1" strike="noStrike">
                 <a:solidFill>
                   <a:srgbClr val="000000"/>
@@ -4476,7 +4476,7 @@
               </a:lnSpc>
               <a:buNone/>
             </a:pPr>
-            <a:fld id="{F6AB042E-AA30-464B-A00C-850F06558825}" type="slidenum">
+            <a:fld id="{97B60E76-6E7D-4E94-975F-BA9A9B8EB2EF}" type="slidenum">
               <a:rPr b="0" lang="en-US" sz="1200" spc="-1" strike="noStrike">
                 <a:solidFill>
                   <a:srgbClr val="000000"/>
@@ -4639,7 +4639,7 @@
               </a:lnSpc>
               <a:buNone/>
             </a:pPr>
-            <a:fld id="{22ED7112-FDCC-4960-B4AA-CF3A743D4A74}" type="slidenum">
+            <a:fld id="{CF2ADAD6-C093-4468-A0DD-FD856F58E964}" type="slidenum">
               <a:rPr b="0" lang="en-US" sz="1200" spc="-1" strike="noStrike">
                 <a:solidFill>
                   <a:srgbClr val="000000"/>
@@ -4802,7 +4802,7 @@
               </a:lnSpc>
               <a:buNone/>
             </a:pPr>
-            <a:fld id="{43F29CAC-101C-45A8-81F9-2FD2A6E327C1}" type="slidenum">
+            <a:fld id="{BF516641-D002-41FC-B600-8DC3D1A875F1}" type="slidenum">
               <a:rPr b="0" lang="en-US" sz="1200" spc="-1" strike="noStrike">
                 <a:solidFill>
                   <a:srgbClr val="000000"/>
@@ -4965,7 +4965,7 @@
               </a:lnSpc>
               <a:buNone/>
             </a:pPr>
-            <a:fld id="{0509C40E-59B3-43B4-9919-F230A8E8C983}" type="slidenum">
+            <a:fld id="{F6D7C69D-04D4-4CF4-96F9-51BE74AF6F37}" type="slidenum">
               <a:rPr b="0" lang="en-US" sz="1200" spc="-1" strike="noStrike">
                 <a:solidFill>
                   <a:srgbClr val="000000"/>
@@ -5128,7 +5128,7 @@
               </a:lnSpc>
               <a:buNone/>
             </a:pPr>
-            <a:fld id="{F8AEFE48-446B-40FF-8099-23656EEFC8EB}" type="slidenum">
+            <a:fld id="{A9167F4F-064F-4F1B-B33D-DD89ED69D757}" type="slidenum">
               <a:rPr b="0" lang="en-US" sz="1200" spc="-1" strike="noStrike">
                 <a:solidFill>
                   <a:srgbClr val="000000"/>
@@ -5291,7 +5291,7 @@
               </a:lnSpc>
               <a:buNone/>
             </a:pPr>
-            <a:fld id="{CDFEF3E7-505B-4122-937A-16A0D7CD3237}" type="slidenum">
+            <a:fld id="{2DE957BE-8DC6-4DE0-9916-032B8E8563AF}" type="slidenum">
               <a:rPr b="0" lang="en-US" sz="1200" spc="-1" strike="noStrike">
                 <a:solidFill>
                   <a:srgbClr val="000000"/>
@@ -5454,7 +5454,7 @@
               </a:lnSpc>
               <a:buNone/>
             </a:pPr>
-            <a:fld id="{48F08E87-C4C2-47E6-99D4-19D54DCBCDFA}" type="slidenum">
+            <a:fld id="{CF4D05A2-3F4D-4EAA-B8FB-7D50DE0A69AD}" type="slidenum">
               <a:rPr b="0" lang="en-US" sz="1200" spc="-1" strike="noStrike">
                 <a:solidFill>
                   <a:srgbClr val="000000"/>
@@ -5617,7 +5617,7 @@
               </a:lnSpc>
               <a:buNone/>
             </a:pPr>
-            <a:fld id="{D406063E-C545-413E-B5CB-C654AC9B0F11}" type="slidenum">
+            <a:fld id="{E6DF3A37-BD2F-4AF3-86A4-F94C6BF5F43E}" type="slidenum">
               <a:rPr b="0" lang="en-US" sz="1200" spc="-1" strike="noStrike">
                 <a:solidFill>
                   <a:srgbClr val="000000"/>
@@ -5780,7 +5780,7 @@
               </a:lnSpc>
               <a:buNone/>
             </a:pPr>
-            <a:fld id="{5B51C0A3-782F-492F-B6F0-8C100B44D29D}" type="slidenum">
+            <a:fld id="{9DD2D69C-F929-45DE-8AF3-8E8454FC6F47}" type="slidenum">
               <a:rPr b="0" lang="en-US" sz="1200" spc="-1" strike="noStrike">
                 <a:solidFill>
                   <a:srgbClr val="000000"/>
@@ -5943,7 +5943,7 @@
               </a:lnSpc>
               <a:buNone/>
             </a:pPr>
-            <a:fld id="{36B506C9-44D2-4E0D-B1E6-9A651ECAD8A0}" type="slidenum">
+            <a:fld id="{CE190024-EC6F-41A4-A309-1FB1D63406AA}" type="slidenum">
               <a:rPr b="0" lang="en-US" sz="1200" spc="-1" strike="noStrike">
                 <a:solidFill>
                   <a:srgbClr val="000000"/>
@@ -6106,7 +6106,7 @@
               </a:lnSpc>
               <a:buNone/>
             </a:pPr>
-            <a:fld id="{063310EA-8031-4C76-92E1-FB9ED525FE06}" type="slidenum">
+            <a:fld id="{31495A21-F52D-4CED-9532-7FF704C1DAAD}" type="slidenum">
               <a:rPr b="0" lang="en-US" sz="1200" spc="-1" strike="noStrike">
                 <a:solidFill>
                   <a:srgbClr val="000000"/>
@@ -6269,7 +6269,7 @@
               </a:lnSpc>
               <a:buNone/>
             </a:pPr>
-            <a:fld id="{76018BC3-85B5-4807-9858-5A99E063CC49}" type="slidenum">
+            <a:fld id="{7E56DA0F-EFE8-4E62-8906-6DB607D7C778}" type="slidenum">
               <a:rPr b="0" lang="en-US" sz="1200" spc="-1" strike="noStrike">
                 <a:solidFill>
                   <a:srgbClr val="000000"/>
@@ -6432,7 +6432,7 @@
               </a:lnSpc>
               <a:buNone/>
             </a:pPr>
-            <a:fld id="{E88C9CC3-967E-4D07-AABA-06AC48661E07}" type="slidenum">
+            <a:fld id="{DA367DDD-7B31-47A4-8ADB-CC3029522587}" type="slidenum">
               <a:rPr b="0" lang="en-US" sz="1200" spc="-1" strike="noStrike">
                 <a:solidFill>
                   <a:srgbClr val="000000"/>
@@ -6595,7 +6595,7 @@
               </a:lnSpc>
               <a:buNone/>
             </a:pPr>
-            <a:fld id="{333E5880-D67D-40E3-BF7A-76103CDD381F}" type="slidenum">
+            <a:fld id="{F6A5D7E6-163B-43F0-ADCA-E696CCC9E926}" type="slidenum">
               <a:rPr b="0" lang="en-US" sz="1200" spc="-1" strike="noStrike">
                 <a:solidFill>
                   <a:srgbClr val="000000"/>
@@ -6758,7 +6758,7 @@
               </a:lnSpc>
               <a:buNone/>
             </a:pPr>
-            <a:fld id="{39CB6922-6C97-4E3A-8D4D-41BF875E490C}" type="slidenum">
+            <a:fld id="{995E7F69-AE00-4436-81CD-E609494D21EB}" type="slidenum">
               <a:rPr b="0" lang="en-US" sz="1200" spc="-1" strike="noStrike">
                 <a:solidFill>
                   <a:srgbClr val="000000"/>
@@ -6921,7 +6921,7 @@
               </a:lnSpc>
               <a:buNone/>
             </a:pPr>
-            <a:fld id="{647E44CA-566D-4230-A515-7459D6EA6DA8}" type="slidenum">
+            <a:fld id="{C0FB9C3F-E59B-41F9-ADD7-62C6A155DAF2}" type="slidenum">
               <a:rPr b="0" lang="en-US" sz="1200" spc="-1" strike="noStrike">
                 <a:solidFill>
                   <a:srgbClr val="000000"/>
@@ -7084,7 +7084,7 @@
               </a:lnSpc>
               <a:buNone/>
             </a:pPr>
-            <a:fld id="{FC79C956-7FBE-4E12-BD9C-9FAF0FB736C8}" type="slidenum">
+            <a:fld id="{4133BDC9-3EB4-4FD6-B338-BD2A5253F31A}" type="slidenum">
               <a:rPr b="0" lang="en-US" sz="1200" spc="-1" strike="noStrike">
                 <a:solidFill>
                   <a:srgbClr val="000000"/>
@@ -7247,7 +7247,7 @@
               </a:lnSpc>
               <a:buNone/>
             </a:pPr>
-            <a:fld id="{4088D479-B1DE-47B6-B4B6-FA71AF445649}" type="slidenum">
+            <a:fld id="{35930AF3-93BE-48FB-AEF7-B51FBE17BA7A}" type="slidenum">
               <a:rPr b="0" lang="en-US" sz="1200" spc="-1" strike="noStrike">
                 <a:solidFill>
                   <a:srgbClr val="000000"/>
@@ -7410,7 +7410,7 @@
               </a:lnSpc>
               <a:buNone/>
             </a:pPr>
-            <a:fld id="{90B3FC16-7586-4709-B0E6-0158C4A9044A}" type="slidenum">
+            <a:fld id="{71183192-02DE-494D-991B-B70ECCD8DE63}" type="slidenum">
               <a:rPr b="0" lang="en-US" sz="1200" spc="-1" strike="noStrike">
                 <a:solidFill>
                   <a:srgbClr val="000000"/>
@@ -7573,7 +7573,7 @@
               </a:lnSpc>
               <a:buNone/>
             </a:pPr>
-            <a:fld id="{9CA6BFDE-10BD-443A-AA37-EC09A7DAC4E5}" type="slidenum">
+            <a:fld id="{0C1BA29A-954A-4445-86EE-0BA0F9A73143}" type="slidenum">
               <a:rPr b="0" lang="en-US" sz="1200" spc="-1" strike="noStrike">
                 <a:solidFill>
                   <a:srgbClr val="000000"/>
@@ -7736,7 +7736,7 @@
               </a:lnSpc>
               <a:buNone/>
             </a:pPr>
-            <a:fld id="{70A452B6-7BB8-4368-9C2F-C810B4109952}" type="slidenum">
+            <a:fld id="{D2E7F886-A519-4E0B-A2CE-03D71306BD63}" type="slidenum">
               <a:rPr b="0" lang="en-US" sz="1200" spc="-1" strike="noStrike">
                 <a:solidFill>
                   <a:srgbClr val="000000"/>
@@ -7899,7 +7899,7 @@
               </a:lnSpc>
               <a:buNone/>
             </a:pPr>
-            <a:fld id="{82138C2A-66C6-48D2-9062-40054B92294A}" type="slidenum">
+            <a:fld id="{7442B5D3-0D42-4153-AC7B-3AE310BD4109}" type="slidenum">
               <a:rPr b="0" lang="en-US" sz="1200" spc="-1" strike="noStrike">
                 <a:solidFill>
                   <a:srgbClr val="000000"/>
@@ -8062,7 +8062,7 @@
               </a:lnSpc>
               <a:buNone/>
             </a:pPr>
-            <a:fld id="{FDC9592F-26F1-484A-8F77-0F0F0260A689}" type="slidenum">
+            <a:fld id="{C75B645E-E800-4FAF-AD76-D73EA642B651}" type="slidenum">
               <a:rPr b="0" lang="en-US" sz="1200" spc="-1" strike="noStrike">
                 <a:solidFill>
                   <a:srgbClr val="000000"/>
@@ -8225,7 +8225,7 @@
               </a:lnSpc>
               <a:buNone/>
             </a:pPr>
-            <a:fld id="{FF08C61D-06CD-4B67-BF72-C606A4AC1405}" type="slidenum">
+            <a:fld id="{FC8AFFB8-B607-4901-B826-3C9C1F457342}" type="slidenum">
               <a:rPr b="0" lang="en-US" sz="1200" spc="-1" strike="noStrike">
                 <a:solidFill>
                   <a:srgbClr val="000000"/>
@@ -8388,7 +8388,7 @@
               </a:lnSpc>
               <a:buNone/>
             </a:pPr>
-            <a:fld id="{EABD66F1-F3AA-4FC5-980C-22C09B4C7B23}" type="slidenum">
+            <a:fld id="{8B2071D2-D0D9-49AF-B759-47BF80A44FE3}" type="slidenum">
               <a:rPr b="0" lang="en-US" sz="1200" spc="-1" strike="noStrike">
                 <a:solidFill>
                   <a:srgbClr val="000000"/>
@@ -8551,7 +8551,7 @@
               </a:lnSpc>
               <a:buNone/>
             </a:pPr>
-            <a:fld id="{AD36C312-EB4F-4B77-A419-1D9B5D4C08D1}" type="slidenum">
+            <a:fld id="{8A0FDD69-B9D4-4A66-AE2A-F5F1B57AFBCE}" type="slidenum">
               <a:rPr b="0" lang="en-US" sz="1200" spc="-1" strike="noStrike">
                 <a:solidFill>
                   <a:srgbClr val="000000"/>
@@ -8714,7 +8714,7 @@
               </a:lnSpc>
               <a:buNone/>
             </a:pPr>
-            <a:fld id="{A99D26A8-F32A-4A1C-B703-4FC257043A17}" type="slidenum">
+            <a:fld id="{CA81E219-4C80-4E68-9B8B-F3FB8BB93E22}" type="slidenum">
               <a:rPr b="0" lang="en-US" sz="1200" spc="-1" strike="noStrike">
                 <a:solidFill>
                   <a:srgbClr val="000000"/>
@@ -8877,7 +8877,7 @@
               </a:lnSpc>
               <a:buNone/>
             </a:pPr>
-            <a:fld id="{8AC0D41C-C096-4C97-9DD8-1334503C63C8}" type="slidenum">
+            <a:fld id="{45CE08B4-459A-403C-815F-C449DDDCC264}" type="slidenum">
               <a:rPr b="0" lang="en-US" sz="1200" spc="-1" strike="noStrike">
                 <a:solidFill>
                   <a:srgbClr val="000000"/>
@@ -9031,7 +9031,7 @@
         <p:txBody>
           <a:bodyPr/>
           <a:p>
-            <a:fld id="{64277C85-6A2E-407E-BFFF-97C399E9A9FD}" type="slidenum">
+            <a:fld id="{05146940-E32B-4E98-BF94-50E99B18B9DF}" type="slidenum">
               <a:t>&lt;#&gt;</a:t>
             </a:fld>
           </a:p>
@@ -9114,7 +9114,7 @@
         <p:txBody>
           <a:bodyPr/>
           <a:p>
-            <a:fld id="{0AD4C228-B9C7-4660-B93F-D0A0DB2C854A}" type="slidenum">
+            <a:fld id="{7951C6AB-4256-43AE-8024-6501A1C9BAA1}" type="slidenum">
               <a:t>&lt;#&gt;</a:t>
             </a:fld>
           </a:p>
@@ -9197,7 +9197,7 @@
         <p:txBody>
           <a:bodyPr/>
           <a:p>
-            <a:fld id="{FC970BD8-ABB0-4B82-B9AF-ABAAA9E1C223}" type="slidenum">
+            <a:fld id="{E3407601-275A-45F9-B8D9-49F1F390D7AB}" type="slidenum">
               <a:t>&lt;#&gt;</a:t>
             </a:fld>
           </a:p>
@@ -9280,7 +9280,7 @@
         <p:txBody>
           <a:bodyPr/>
           <a:p>
-            <a:fld id="{02EE94D5-2100-4A0B-B5ED-2B51D92FCB19}" type="slidenum">
+            <a:fld id="{1AE73310-6DD7-4D8E-B249-7DCDC3FEFB64}" type="slidenum">
               <a:t>&lt;#&gt;</a:t>
             </a:fld>
           </a:p>
@@ -9363,7 +9363,7 @@
         <p:txBody>
           <a:bodyPr/>
           <a:p>
-            <a:fld id="{F562FE3E-4D7F-4110-89EB-B81A5EA2D357}" type="slidenum">
+            <a:fld id="{74117FFD-532C-44CB-BCAD-5794D5403BF7}" type="slidenum">
               <a:t>&lt;#&gt;</a:t>
             </a:fld>
           </a:p>
@@ -9529,7 +9529,7 @@
         <p:txBody>
           <a:bodyPr/>
           <a:p>
-            <a:fld id="{E24F3575-09D9-4B14-ABC1-F08BFC9E9DDF}" type="slidenum">
+            <a:fld id="{09CA3DA1-3C8D-4AE2-997E-6A48254F48AC}" type="slidenum">
               <a:t>&lt;#&gt;</a:t>
             </a:fld>
           </a:p>
@@ -9612,7 +9612,7 @@
         <p:txBody>
           <a:bodyPr/>
           <a:p>
-            <a:fld id="{0683B579-B2BB-4D3B-929E-681B47383AB7}" type="slidenum">
+            <a:fld id="{4EBF1B07-2EE6-4732-A93D-2B223F5AB2FD}" type="slidenum">
               <a:t>&lt;#&gt;</a:t>
             </a:fld>
           </a:p>
@@ -9821,7 +9821,7 @@
         <p:txBody>
           <a:bodyPr/>
           <a:p>
-            <a:fld id="{04256A24-AB82-49F2-9E04-5B3A96C5463C}" type="slidenum">
+            <a:fld id="{04E5409C-4A5C-4ABB-93D0-5976EBB3CAE9}" type="slidenum">
               <a:t>&lt;#&gt;</a:t>
             </a:fld>
           </a:p>
@@ -9904,7 +9904,7 @@
         <p:txBody>
           <a:bodyPr/>
           <a:p>
-            <a:fld id="{2B8B7BB2-2BC7-4158-B691-AFC2761B1603}" type="slidenum">
+            <a:fld id="{0D1B8DDF-8980-43B6-B5DB-793455FE64CD}" type="slidenum">
               <a:t>&lt;#&gt;</a:t>
             </a:fld>
           </a:p>
@@ -10027,7 +10027,7 @@
         <p:txBody>
           <a:bodyPr/>
           <a:p>
-            <a:fld id="{EB9741AD-158A-4DF7-B765-A82974EAB4AD}" type="slidenum">
+            <a:fld id="{3DDC1959-A1D9-414F-8E10-70AC55906B65}" type="slidenum">
               <a:t>&lt;#&gt;</a:t>
             </a:fld>
           </a:p>
@@ -10110,7 +10110,7 @@
         <p:txBody>
           <a:bodyPr/>
           <a:p>
-            <a:fld id="{3C4C2567-8398-4254-9EC4-C8B7305EFF99}" type="slidenum">
+            <a:fld id="{46C82CFC-6B59-4ADF-93E0-006FB47CDCE6}" type="slidenum">
               <a:t>&lt;#&gt;</a:t>
             </a:fld>
           </a:p>
@@ -10398,7 +10398,7 @@
               </a:lnSpc>
               <a:buNone/>
             </a:pPr>
-            <a:fld id="{6E42C905-C6A9-4D63-879F-54CD9851FE7C}" type="slidenum">
+            <a:fld id="{64A84A0A-7D90-4B45-8513-2638572EB906}" type="slidenum">
               <a:rPr b="0" lang="en-US" sz="1200" spc="-1" strike="noStrike">
                 <a:solidFill>
                   <a:schemeClr val="dk1">
@@ -10920,7 +10920,7 @@
               </a:lnSpc>
               <a:buNone/>
             </a:pPr>
-            <a:fld id="{E1818850-0586-4C5A-9BF2-A8E01340B0BE}" type="slidenum">
+            <a:fld id="{A0398B23-9081-4C90-9292-7515D88146B2}" type="slidenum">
               <a:rPr b="0" lang="en-US" sz="1200" spc="-1" strike="noStrike">
                 <a:solidFill>
                   <a:schemeClr val="dk1">
@@ -11488,7 +11488,7 @@
               </a:lnSpc>
               <a:buNone/>
             </a:pPr>
-            <a:fld id="{FD5B2616-3435-4056-BAB4-1590AD17EC55}" type="slidenum">
+            <a:fld id="{A075EAC9-D2C7-41BF-B0DD-7C9157265585}" type="slidenum">
               <a:rPr b="0" lang="en-US" sz="1200" spc="-1" strike="noStrike">
                 <a:solidFill>
                   <a:schemeClr val="dk1">
@@ -11952,7 +11952,7 @@
               </a:lnSpc>
               <a:buNone/>
             </a:pPr>
-            <a:fld id="{05B52BA2-6875-4424-BB2E-07C5AF0F4A56}" type="slidenum">
+            <a:fld id="{D9DA0EA5-ADDC-41F7-BAFC-26AA3A534D75}" type="slidenum">
               <a:rPr b="0" lang="en-US" sz="1200" spc="-1" strike="noStrike">
                 <a:solidFill>
                   <a:schemeClr val="dk1">
@@ -12416,7 +12416,7 @@
               </a:lnSpc>
               <a:buNone/>
             </a:pPr>
-            <a:fld id="{7DE7F5E4-57B3-4DDE-BDC4-F84876EDC31C}" type="slidenum">
+            <a:fld id="{34F91771-A59B-4BBA-855F-837131D82E0E}" type="slidenum">
               <a:rPr b="0" lang="en-US" sz="1200" spc="-1" strike="noStrike">
                 <a:solidFill>
                   <a:schemeClr val="dk1">
@@ -12880,7 +12880,7 @@
               </a:lnSpc>
               <a:buNone/>
             </a:pPr>
-            <a:fld id="{B29FDEAC-8C29-4209-8530-4F02CFEBD375}" type="slidenum">
+            <a:fld id="{33F3E494-492D-4303-9518-FEB59D13F316}" type="slidenum">
               <a:rPr b="0" lang="en-US" sz="1200" spc="-1" strike="noStrike">
                 <a:solidFill>
                   <a:schemeClr val="dk1">
@@ -13225,7 +13225,7 @@
               </a:lnSpc>
               <a:buNone/>
             </a:pPr>
-            <a:fld id="{2BAB112B-1946-4865-9E98-2F9211E87640}" type="slidenum">
+            <a:fld id="{54434E55-F840-4776-883A-4D4295A0A12E}" type="slidenum">
               <a:rPr b="0" lang="en-US" sz="1200" spc="-1" strike="noStrike">
                 <a:solidFill>
                   <a:schemeClr val="dk1">
@@ -13868,7 +13868,7 @@
               </a:lnSpc>
               <a:buNone/>
             </a:pPr>
-            <a:fld id="{494540F2-AE48-44FD-9F4B-B7D14E5BD43E}" type="slidenum">
+            <a:fld id="{9CB6EA4F-4501-46A9-B514-C3E653BB3FD4}" type="slidenum">
               <a:rPr b="0" lang="en-US" sz="1200" spc="-1" strike="noStrike">
                 <a:solidFill>
                   <a:schemeClr val="dk1">
@@ -14627,7 +14627,7 @@
               </a:lnSpc>
               <a:buNone/>
             </a:pPr>
-            <a:fld id="{D57C9F76-D340-433C-A3A2-074AE55FCA3C}" type="slidenum">
+            <a:fld id="{9198DC47-BD13-4E7F-A08E-6FF8EE11AE7A}" type="slidenum">
               <a:rPr b="0" lang="en-US" sz="1200" spc="-1" strike="noStrike">
                 <a:solidFill>
                   <a:schemeClr val="dk1">
@@ -14912,7 +14912,7 @@
               </a:lnSpc>
               <a:buNone/>
             </a:pPr>
-            <a:fld id="{FCA6859B-B08B-46EA-B555-8B661793EDA4}" type="slidenum">
+            <a:fld id="{7C74B5E8-DD84-4536-B753-5B26A1877576}" type="slidenum">
               <a:rPr b="0" lang="en-US" sz="1200" spc="-1" strike="noStrike">
                 <a:solidFill>
                   <a:schemeClr val="dk1">
@@ -15145,7 +15145,7 @@
               </a:lnSpc>
               <a:buNone/>
             </a:pPr>
-            <a:fld id="{4E876762-FDF0-4F2D-9632-BC3B3C89CA70}" type="slidenum">
+            <a:fld id="{3A4FCF0D-0119-468D-A368-5B5A99EA13B3}" type="slidenum">
               <a:rPr b="0" lang="en-US" sz="1200" spc="-1" strike="noStrike">
                 <a:solidFill>
                   <a:schemeClr val="dk1">
@@ -41647,7 +41647,7 @@
         <p:spPr>
           <a:xfrm>
             <a:off x="548640" y="1005840"/>
-            <a:ext cx="11094120" cy="1293480"/>
+            <a:ext cx="11094120" cy="3197520"/>
           </a:xfrm>
           <a:prstGeom prst="rect">
             <a:avLst/>
@@ -41680,7 +41680,7 @@
                 </a:solidFill>
                 <a:latin typeface="IBM Plex Mono"/>
               </a:rPr>
-              <a:t>Rhonda / CounterSpy 2026, Atlanta</a:t>
+              <a:t>Rhonda Rhododendron / CounterSpy 2026, Atlanta</a:t>
             </a:r>
             <a:endParaRPr b="0" lang="en-US" sz="1600" spc="-1" strike="noStrike">
               <a:solidFill>
@@ -41754,8 +41754,152 @@
                   <a:srgbClr val="cccccc"/>
                 </a:solidFill>
                 <a:latin typeface="IBM Plex Mono"/>
-              </a:rPr>
-              <a:t>llamenos-hotline.com/slides/counterspy-2026/</a:t>
+                <a:hlinkClick r:id="rId1"/>
+              </a:rPr>
+              <a:t>https://github.com/rhonda-rodododo/llamenos-hotline</a:t>
+            </a:r>
+            <a:endParaRPr b="0" lang="en-US" sz="1600" spc="-1" strike="noStrike">
+              <a:solidFill>
+                <a:srgbClr val="ffffff"/>
+              </a:solidFill>
+              <a:latin typeface="Arial"/>
+            </a:endParaRPr>
+          </a:p>
+          <a:p>
+            <a:pPr defTabSz="457200">
+              <a:lnSpc>
+                <a:spcPct val="100000"/>
+              </a:lnSpc>
+              <a:spcBef>
+                <a:spcPts val="300"/>
+              </a:spcBef>
+              <a:spcAft>
+                <a:spcPts val="201"/>
+              </a:spcAft>
+            </a:pPr>
+            <a:endParaRPr b="0" lang="en-US" sz="1600" spc="-1" strike="noStrike">
+              <a:solidFill>
+                <a:srgbClr val="ffffff"/>
+              </a:solidFill>
+              <a:latin typeface="Arial"/>
+            </a:endParaRPr>
+          </a:p>
+          <a:p>
+            <a:pPr defTabSz="457200">
+              <a:lnSpc>
+                <a:spcPct val="100000"/>
+              </a:lnSpc>
+              <a:spcBef>
+                <a:spcPts val="300"/>
+              </a:spcBef>
+              <a:spcAft>
+                <a:spcPts val="201"/>
+              </a:spcAft>
+            </a:pPr>
+            <a:r>
+              <a:rPr b="0" lang="en-US" sz="1600" spc="-1" strike="noStrike">
+                <a:solidFill>
+                  <a:srgbClr val="cccccc"/>
+                </a:solidFill>
+                <a:latin typeface="IBM Plex Mono"/>
+                <a:hlinkClick r:id="rId2"/>
+              </a:rPr>
+              <a:t>https://llamenos-hotline.com/</a:t>
+            </a:r>
+            <a:endParaRPr b="0" lang="en-US" sz="1600" spc="-1" strike="noStrike">
+              <a:solidFill>
+                <a:srgbClr val="ffffff"/>
+              </a:solidFill>
+              <a:latin typeface="Arial"/>
+            </a:endParaRPr>
+          </a:p>
+          <a:p>
+            <a:pPr defTabSz="457200">
+              <a:lnSpc>
+                <a:spcPct val="100000"/>
+              </a:lnSpc>
+              <a:spcBef>
+                <a:spcPts val="300"/>
+              </a:spcBef>
+              <a:spcAft>
+                <a:spcPts val="201"/>
+              </a:spcAft>
+            </a:pPr>
+            <a:endParaRPr b="0" lang="en-US" sz="1600" spc="-1" strike="noStrike">
+              <a:solidFill>
+                <a:srgbClr val="ffffff"/>
+              </a:solidFill>
+              <a:latin typeface="Arial"/>
+            </a:endParaRPr>
+          </a:p>
+          <a:p>
+            <a:pPr defTabSz="457200">
+              <a:lnSpc>
+                <a:spcPct val="100000"/>
+              </a:lnSpc>
+              <a:spcBef>
+                <a:spcPts val="300"/>
+              </a:spcBef>
+              <a:spcAft>
+                <a:spcPts val="201"/>
+              </a:spcAft>
+            </a:pPr>
+            <a:r>
+              <a:rPr b="0" lang="en-US" sz="1600" spc="-1" strike="noStrike">
+                <a:solidFill>
+                  <a:srgbClr val="cccccc"/>
+                </a:solidFill>
+                <a:latin typeface="IBM Plex Mono"/>
+                <a:hlinkClick r:id="rId3"/>
+              </a:rPr>
+              <a:t>https://github.com/rhonda-rodododo/llamenos-platform/tree/main/site/public/slides</a:t>
+            </a:r>
+            <a:endParaRPr b="0" lang="en-US" sz="1600" spc="-1" strike="noStrike">
+              <a:solidFill>
+                <a:srgbClr val="ffffff"/>
+              </a:solidFill>
+              <a:latin typeface="Arial"/>
+            </a:endParaRPr>
+          </a:p>
+          <a:p>
+            <a:pPr defTabSz="457200">
+              <a:lnSpc>
+                <a:spcPct val="100000"/>
+              </a:lnSpc>
+              <a:spcBef>
+                <a:spcPts val="300"/>
+              </a:spcBef>
+              <a:spcAft>
+                <a:spcPts val="201"/>
+              </a:spcAft>
+            </a:pPr>
+            <a:endParaRPr b="0" lang="en-US" sz="1600" spc="-1" strike="noStrike">
+              <a:solidFill>
+                <a:srgbClr val="ffffff"/>
+              </a:solidFill>
+              <a:latin typeface="Arial"/>
+            </a:endParaRPr>
+          </a:p>
+          <a:p>
+            <a:pPr defTabSz="457200">
+              <a:lnSpc>
+                <a:spcPct val="100000"/>
+              </a:lnSpc>
+              <a:spcBef>
+                <a:spcPts val="300"/>
+              </a:spcBef>
+              <a:spcAft>
+                <a:spcPts val="201"/>
+              </a:spcAft>
+            </a:pPr>
+            <a:r>
+              <a:rPr b="0" lang="en-US" sz="1600" spc="-1" strike="noStrike">
+                <a:solidFill>
+                  <a:srgbClr val="cccccc"/>
+                </a:solidFill>
+                <a:latin typeface="IBM Plex Mono"/>
+              </a:rPr>
+              <a:t>https://cryptpad.fr/drive/#/2/drive/view/upMpFMAvdGSjlCyjKBMPuIfS8c+pW0Lt9c9JWqB5swM/</a:t>
             </a:r>
             <a:endParaRPr b="0" lang="en-US" sz="1600" spc="-1" strike="noStrike">
               <a:solidFill>

</xml_diff>